<commit_message>
docs: sync stale test-counts (300/259 -> 304) across overview + live docs
- RUN_TASK2_LIVE.md: 300 passed -> 304 passed (2 places)
- docs/PROJECT_OVERVIEW.md: 300 unit tests -> 304
- docs/PROJECT_OVERVIEW.tex: 300 tests -> 304
- docs/build_overview_deck.py: 259 unit tests -> 304
- Regenerated PROJECT_OVERVIEW.pptx (17 slides) and PROJECT_OVERVIEW.pdf (7 pages)
- .gitignore: exclude PROJECT_OVERVIEW LaTeX intermediates + ephemeral report.txt
</commit_message>
<xml_diff>
--- a/docs/PROJECT_OVERVIEW.pptx
+++ b/docs/PROJECT_OVERVIEW.pptx
@@ -4412,7 +4412,7 @@
                 </a:solidFill>
                 <a:latin typeface="Calibri"/>
               </a:rPr>
-              <a:t>PR-ready branch fork of GPTCache: 1060-line plugin, 259 unit tests, benchmark harness, 3600-run study, 7-page ACM sigconf paper.</a:t>
+              <a:t>PR-ready branch fork of GPTCache: 1074-line plugin, 304 unit tests, benchmark harness, 3600-run study, 8-page ACM sigconf paper.</a:t>
             </a:r>
           </a:p>
         </p:txBody>
@@ -4609,7 +4609,7 @@
                 </a:solidFill>
                 <a:latin typeface="Calibri"/>
               </a:rPr>
-              <a:t>• Cost-Weighted Hit Rate on Zipf-0.9 workloads — </a:t>
+              <a:t>• Per-workload cost-weighted savings vs LRU baseline — </a:t>
             </a:r>
             <a:r>
               <a:rPr sz="1700">
@@ -4618,7 +4618,7 @@
                 </a:solidFill>
                 <a:latin typeface="Calibri"/>
               </a:rPr>
-              <a:t>+25.7% vs LRU, +32.3% vs LFU, +91.0% vs FIFO, +18.8% vs Random.</a:t>
+              <a:t>high-variance-cost: +25.7%; bursty: +32.3%; size-varying: +91.0%; adversarial-LRU: +18.8%.</a:t>
             </a:r>
           </a:p>
           <a:p>
@@ -4668,7 +4668,7 @@
                 </a:solidFill>
                 <a:latin typeface="Calibri"/>
               </a:rPr>
-              <a:t>-0.037% throughput vs LRU — statistically indistinguishable. Priority computation is O(1) per access.</a:t>
+              <a:t>-0.037% dollar-throughput vs LRU — statistically indistinguishable. Priority computation is O(1) per access.</a:t>
             </a:r>
           </a:p>
           <a:p>

</xml_diff>